<commit_message>
Ajuste eje Y en gráfica: porcentaje con divisiones cada 5%
</commit_message>
<xml_diff>
--- a/2.EDA_Titanic_Datasheet/Presentacion_Titanic.pptx
+++ b/2.EDA_Titanic_Datasheet/Presentacion_Titanic.pptx
@@ -1062,15 +1062,15 @@
 </file>
 
 <file path=ppt/diagrams/colors2.xml><?xml version="1.0" encoding="utf-8"?>
-<dgm:colorsDef xmlns:dgm="http://schemas.openxmlformats.org/drawingml/2006/diagram" xmlns:a="http://schemas.openxmlformats.org/drawingml/2006/main" uniqueId="urn:microsoft.com/office/officeart/2018/5/colors/Iconchunking_neutralicon_colorful1">
+<dgm:colorsDef xmlns:dgm="http://schemas.openxmlformats.org/drawingml/2006/diagram" xmlns:a="http://schemas.openxmlformats.org/drawingml/2006/main" uniqueId="urn:microsoft.com/office/officeart/2018/5/colors/Iconchunking_neutralicon_accent3_2">
   <dgm:title val=""/>
   <dgm:desc val=""/>
   <dgm:catLst>
-    <dgm:cat type="colorful" pri="10100"/>
+    <dgm:cat type="accent3" pri="13200"/>
   </dgm:catLst>
   <dgm:styleLbl name="node0">
     <dgm:fillClrLst meth="repeat">
-      <a:schemeClr val="accent1"/>
+      <a:schemeClr val="accent3"/>
     </dgm:fillClrLst>
     <dgm:linClrLst meth="repeat">
       <a:schemeClr val="lt1"/>
@@ -1098,18 +1098,10 @@
   </dgm:styleLbl>
   <dgm:styleLbl name="alignNode1">
     <dgm:fillClrLst meth="repeat">
-      <a:schemeClr val="accent2"/>
       <a:schemeClr val="accent3"/>
-      <a:schemeClr val="accent4"/>
-      <a:schemeClr val="accent5"/>
-      <a:schemeClr val="accent6"/>
     </dgm:fillClrLst>
     <dgm:linClrLst meth="repeat">
-      <a:schemeClr val="accent2"/>
       <a:schemeClr val="accent3"/>
-      <a:schemeClr val="accent4"/>
-      <a:schemeClr val="accent5"/>
-      <a:schemeClr val="accent6"/>
     </dgm:linClrLst>
     <dgm:effectClrLst/>
     <dgm:txLinClrLst/>
@@ -1118,11 +1110,7 @@
   </dgm:styleLbl>
   <dgm:styleLbl name="lnNode1">
     <dgm:fillClrLst meth="repeat">
-      <a:schemeClr val="accent2"/>
       <a:schemeClr val="accent3"/>
-      <a:schemeClr val="accent4"/>
-      <a:schemeClr val="accent5"/>
-      <a:schemeClr val="accent6"/>
     </dgm:fillClrLst>
     <dgm:linClrLst meth="repeat">
       <a:schemeClr val="lt1"/>
@@ -1134,19 +1122,7 @@
   </dgm:styleLbl>
   <dgm:styleLbl name="vennNode1">
     <dgm:fillClrLst meth="repeat">
-      <a:schemeClr val="accent2">
-        <a:alpha val="50000"/>
-      </a:schemeClr>
       <a:schemeClr val="accent3">
-        <a:alpha val="50000"/>
-      </a:schemeClr>
-      <a:schemeClr val="accent4">
-        <a:alpha val="50000"/>
-      </a:schemeClr>
-      <a:schemeClr val="accent5">
-        <a:alpha val="50000"/>
-      </a:schemeClr>
-      <a:schemeClr val="accent6">
         <a:alpha val="50000"/>
       </a:schemeClr>
     </dgm:fillClrLst>
@@ -1159,19 +1135,7 @@
     <dgm:txEffectClrLst/>
   </dgm:styleLbl>
   <dgm:styleLbl name="node2">
-    <dgm:fillClrLst>
-      <a:schemeClr val="accent2"/>
-    </dgm:fillClrLst>
-    <dgm:linClrLst meth="repeat">
-      <a:schemeClr val="lt1"/>
-    </dgm:linClrLst>
-    <dgm:effectClrLst/>
-    <dgm:txLinClrLst/>
-    <dgm:txFillClrLst/>
-    <dgm:txEffectClrLst/>
-  </dgm:styleLbl>
-  <dgm:styleLbl name="node3">
-    <dgm:fillClrLst>
+    <dgm:fillClrLst meth="repeat">
       <a:schemeClr val="accent3"/>
     </dgm:fillClrLst>
     <dgm:linClrLst meth="repeat">
@@ -1182,9 +1146,9 @@
     <dgm:txFillClrLst/>
     <dgm:txEffectClrLst/>
   </dgm:styleLbl>
-  <dgm:styleLbl name="node4">
-    <dgm:fillClrLst>
-      <a:schemeClr val="accent4"/>
+  <dgm:styleLbl name="node3">
+    <dgm:fillClrLst meth="repeat">
+      <a:schemeClr val="accent3"/>
     </dgm:fillClrLst>
     <dgm:linClrLst meth="repeat">
       <a:schemeClr val="lt1"/>
@@ -1194,21 +1158,21 @@
     <dgm:txFillClrLst/>
     <dgm:txEffectClrLst/>
   </dgm:styleLbl>
+  <dgm:styleLbl name="node4">
+    <dgm:fillClrLst meth="repeat">
+      <a:schemeClr val="accent3"/>
+    </dgm:fillClrLst>
+    <dgm:linClrLst meth="repeat">
+      <a:schemeClr val="lt1"/>
+    </dgm:linClrLst>
+    <dgm:effectClrLst/>
+    <dgm:txLinClrLst/>
+    <dgm:txFillClrLst/>
+    <dgm:txEffectClrLst/>
+  </dgm:styleLbl>
   <dgm:styleLbl name="fgImgPlace1">
     <dgm:fillClrLst meth="repeat">
-      <a:schemeClr val="accent2">
-        <a:tint val="50000"/>
-      </a:schemeClr>
       <a:schemeClr val="accent3">
-        <a:tint val="50000"/>
-      </a:schemeClr>
-      <a:schemeClr val="accent4">
-        <a:tint val="50000"/>
-      </a:schemeClr>
-      <a:schemeClr val="accent5">
-        <a:tint val="50000"/>
-      </a:schemeClr>
-      <a:schemeClr val="accent6">
         <a:tint val="50000"/>
       </a:schemeClr>
     </dgm:fillClrLst>
@@ -1223,12 +1187,9 @@
     <dgm:txEffectClrLst/>
   </dgm:styleLbl>
   <dgm:styleLbl name="alignImgPlace1">
-    <dgm:fillClrLst>
-      <a:schemeClr val="accent1">
+    <dgm:fillClrLst meth="repeat">
+      <a:schemeClr val="accent3">
         <a:tint val="50000"/>
-      </a:schemeClr>
-      <a:schemeClr val="accent2">
-        <a:tint val="20000"/>
       </a:schemeClr>
     </dgm:fillClrLst>
     <dgm:linClrLst meth="repeat">
@@ -1242,12 +1203,9 @@
     <dgm:txEffectClrLst/>
   </dgm:styleLbl>
   <dgm:styleLbl name="bgImgPlace1">
-    <dgm:fillClrLst>
-      <a:schemeClr val="accent1">
+    <dgm:fillClrLst meth="repeat">
+      <a:schemeClr val="accent3">
         <a:tint val="50000"/>
-      </a:schemeClr>
-      <a:schemeClr val="accent2">
-        <a:tint val="20000"/>
       </a:schemeClr>
     </dgm:fillClrLst>
     <dgm:linClrLst meth="repeat">
@@ -1262,14 +1220,14 @@
   </dgm:styleLbl>
   <dgm:styleLbl name="sibTrans2D1">
     <dgm:fillClrLst meth="repeat">
-      <a:schemeClr val="accent2"/>
-      <a:schemeClr val="accent3"/>
-      <a:schemeClr val="accent4"/>
-      <a:schemeClr val="accent5"/>
-      <a:schemeClr val="accent6"/>
+      <a:schemeClr val="accent3">
+        <a:tint val="60000"/>
+      </a:schemeClr>
     </dgm:fillClrLst>
-    <dgm:linClrLst meth="cycle">
-      <a:schemeClr val="lt1"/>
+    <dgm:linClrLst meth="repeat">
+      <a:schemeClr val="accent3">
+        <a:tint val="60000"/>
+      </a:schemeClr>
     </dgm:linClrLst>
     <dgm:effectClrLst/>
     <dgm:txLinClrLst/>
@@ -1278,54 +1236,42 @@
   </dgm:styleLbl>
   <dgm:styleLbl name="fgSibTrans2D1">
     <dgm:fillClrLst meth="repeat">
-      <a:schemeClr val="accent2"/>
-      <a:schemeClr val="accent3"/>
-      <a:schemeClr val="accent4"/>
-      <a:schemeClr val="accent5"/>
-      <a:schemeClr val="accent6"/>
+      <a:schemeClr val="accent3">
+        <a:tint val="60000"/>
+      </a:schemeClr>
     </dgm:fillClrLst>
-    <dgm:linClrLst meth="cycle">
-      <a:schemeClr val="lt1"/>
+    <dgm:linClrLst meth="repeat">
+      <a:schemeClr val="accent3">
+        <a:tint val="60000"/>
+      </a:schemeClr>
     </dgm:linClrLst>
     <dgm:effectClrLst/>
     <dgm:txLinClrLst/>
-    <dgm:txFillClrLst meth="repeat">
-      <a:schemeClr val="lt1"/>
-    </dgm:txFillClrLst>
+    <dgm:txFillClrLst/>
     <dgm:txEffectClrLst/>
   </dgm:styleLbl>
   <dgm:styleLbl name="bgSibTrans2D1">
     <dgm:fillClrLst meth="repeat">
-      <a:schemeClr val="accent2"/>
-      <a:schemeClr val="accent3"/>
-      <a:schemeClr val="accent4"/>
-      <a:schemeClr val="accent5"/>
-      <a:schemeClr val="accent6"/>
+      <a:schemeClr val="accent3">
+        <a:tint val="60000"/>
+      </a:schemeClr>
     </dgm:fillClrLst>
-    <dgm:linClrLst meth="cycle">
-      <a:schemeClr val="lt1"/>
+    <dgm:linClrLst meth="repeat">
+      <a:schemeClr val="accent3">
+        <a:tint val="60000"/>
+      </a:schemeClr>
     </dgm:linClrLst>
     <dgm:effectClrLst/>
     <dgm:txLinClrLst/>
-    <dgm:txFillClrLst meth="repeat">
-      <a:schemeClr val="lt1"/>
-    </dgm:txFillClrLst>
+    <dgm:txFillClrLst/>
     <dgm:txEffectClrLst/>
   </dgm:styleLbl>
   <dgm:styleLbl name="sibTrans1D1">
     <dgm:fillClrLst meth="repeat">
-      <a:schemeClr val="accent2"/>
       <a:schemeClr val="accent3"/>
-      <a:schemeClr val="accent4"/>
-      <a:schemeClr val="accent5"/>
-      <a:schemeClr val="accent6"/>
     </dgm:fillClrLst>
     <dgm:linClrLst meth="repeat">
-      <a:schemeClr val="accent2"/>
       <a:schemeClr val="accent3"/>
-      <a:schemeClr val="accent4"/>
-      <a:schemeClr val="accent5"/>
-      <a:schemeClr val="accent6"/>
     </dgm:linClrLst>
     <dgm:effectClrLst/>
     <dgm:txLinClrLst/>
@@ -1336,10 +1282,10 @@
   </dgm:styleLbl>
   <dgm:styleLbl name="callout">
     <dgm:fillClrLst meth="repeat">
-      <a:schemeClr val="accent2"/>
+      <a:schemeClr val="accent3"/>
     </dgm:fillClrLst>
     <dgm:linClrLst meth="repeat">
-      <a:schemeClr val="accent2">
+      <a:schemeClr val="accent3">
         <a:tint val="50000"/>
       </a:schemeClr>
     </dgm:linClrLst>
@@ -1351,80 +1297,6 @@
     <dgm:txEffectClrLst/>
   </dgm:styleLbl>
   <dgm:styleLbl name="asst0">
-    <dgm:fillClrLst meth="repeat">
-      <a:schemeClr val="accent1"/>
-    </dgm:fillClrLst>
-    <dgm:linClrLst meth="repeat">
-      <a:schemeClr val="lt1"/>
-    </dgm:linClrLst>
-    <dgm:effectClrLst/>
-    <dgm:txLinClrLst/>
-    <dgm:txFillClrLst/>
-    <dgm:txEffectClrLst/>
-  </dgm:styleLbl>
-  <dgm:styleLbl name="asst1">
-    <dgm:fillClrLst meth="repeat">
-      <a:schemeClr val="accent2"/>
-    </dgm:fillClrLst>
-    <dgm:linClrLst meth="repeat">
-      <a:schemeClr val="lt1"/>
-    </dgm:linClrLst>
-    <dgm:effectClrLst/>
-    <dgm:txLinClrLst/>
-    <dgm:txFillClrLst/>
-    <dgm:txEffectClrLst/>
-  </dgm:styleLbl>
-  <dgm:styleLbl name="asst2">
-    <dgm:fillClrLst>
-      <a:schemeClr val="accent3"/>
-    </dgm:fillClrLst>
-    <dgm:linClrLst meth="repeat">
-      <a:schemeClr val="lt1"/>
-    </dgm:linClrLst>
-    <dgm:effectClrLst/>
-    <dgm:txLinClrLst/>
-    <dgm:txFillClrLst/>
-    <dgm:txEffectClrLst/>
-  </dgm:styleLbl>
-  <dgm:styleLbl name="asst3">
-    <dgm:fillClrLst>
-      <a:schemeClr val="accent4"/>
-    </dgm:fillClrLst>
-    <dgm:linClrLst meth="repeat">
-      <a:schemeClr val="lt1"/>
-    </dgm:linClrLst>
-    <dgm:effectClrLst/>
-    <dgm:txLinClrLst/>
-    <dgm:txFillClrLst/>
-    <dgm:txEffectClrLst/>
-  </dgm:styleLbl>
-  <dgm:styleLbl name="asst4">
-    <dgm:fillClrLst>
-      <a:schemeClr val="accent5"/>
-    </dgm:fillClrLst>
-    <dgm:linClrLst meth="repeat">
-      <a:schemeClr val="lt1"/>
-    </dgm:linClrLst>
-    <dgm:effectClrLst/>
-    <dgm:txLinClrLst/>
-    <dgm:txFillClrLst/>
-    <dgm:txEffectClrLst/>
-  </dgm:styleLbl>
-  <dgm:styleLbl name="parChTrans2D1">
-    <dgm:fillClrLst meth="repeat">
-      <a:schemeClr val="accent2"/>
-    </dgm:fillClrLst>
-    <dgm:linClrLst meth="repeat">
-      <a:schemeClr val="lt1"/>
-    </dgm:linClrLst>
-    <dgm:effectClrLst/>
-    <dgm:txLinClrLst/>
-    <dgm:txFillClrLst meth="repeat">
-      <a:schemeClr val="lt1"/>
-    </dgm:txFillClrLst>
-    <dgm:txEffectClrLst/>
-  </dgm:styleLbl>
-  <dgm:styleLbl name="parChTrans2D2">
     <dgm:fillClrLst meth="repeat">
       <a:schemeClr val="accent3"/>
     </dgm:fillClrLst>
@@ -1436,9 +1308,9 @@
     <dgm:txFillClrLst/>
     <dgm:txEffectClrLst/>
   </dgm:styleLbl>
-  <dgm:styleLbl name="parChTrans2D3">
+  <dgm:styleLbl name="asst1">
     <dgm:fillClrLst meth="repeat">
-      <a:schemeClr val="accent4"/>
+      <a:schemeClr val="accent3"/>
     </dgm:fillClrLst>
     <dgm:linClrLst meth="repeat">
       <a:schemeClr val="lt1"/>
@@ -1448,12 +1320,52 @@
     <dgm:txFillClrLst/>
     <dgm:txEffectClrLst/>
   </dgm:styleLbl>
-  <dgm:styleLbl name="parChTrans2D4">
+  <dgm:styleLbl name="asst2">
     <dgm:fillClrLst meth="repeat">
-      <a:schemeClr val="accent5"/>
+      <a:schemeClr val="accent3"/>
     </dgm:fillClrLst>
     <dgm:linClrLst meth="repeat">
       <a:schemeClr val="lt1"/>
+    </dgm:linClrLst>
+    <dgm:effectClrLst/>
+    <dgm:txLinClrLst/>
+    <dgm:txFillClrLst/>
+    <dgm:txEffectClrLst/>
+  </dgm:styleLbl>
+  <dgm:styleLbl name="asst3">
+    <dgm:fillClrLst meth="repeat">
+      <a:schemeClr val="accent3"/>
+    </dgm:fillClrLst>
+    <dgm:linClrLst meth="repeat">
+      <a:schemeClr val="lt1"/>
+    </dgm:linClrLst>
+    <dgm:effectClrLst/>
+    <dgm:txLinClrLst/>
+    <dgm:txFillClrLst/>
+    <dgm:txEffectClrLst/>
+  </dgm:styleLbl>
+  <dgm:styleLbl name="asst4">
+    <dgm:fillClrLst meth="repeat">
+      <a:schemeClr val="accent3"/>
+    </dgm:fillClrLst>
+    <dgm:linClrLst meth="repeat">
+      <a:schemeClr val="lt1"/>
+    </dgm:linClrLst>
+    <dgm:effectClrLst/>
+    <dgm:txLinClrLst/>
+    <dgm:txFillClrLst/>
+    <dgm:txEffectClrLst/>
+  </dgm:styleLbl>
+  <dgm:styleLbl name="parChTrans2D1">
+    <dgm:fillClrLst meth="repeat">
+      <a:schemeClr val="accent3">
+        <a:tint val="60000"/>
+      </a:schemeClr>
+    </dgm:fillClrLst>
+    <dgm:linClrLst meth="repeat">
+      <a:schemeClr val="accent3">
+        <a:tint val="60000"/>
+      </a:schemeClr>
     </dgm:linClrLst>
     <dgm:effectClrLst/>
     <dgm:txLinClrLst/>
@@ -1462,12 +1374,56 @@
     </dgm:txFillClrLst>
     <dgm:txEffectClrLst/>
   </dgm:styleLbl>
+  <dgm:styleLbl name="parChTrans2D2">
+    <dgm:fillClrLst meth="repeat">
+      <a:schemeClr val="accent3"/>
+    </dgm:fillClrLst>
+    <dgm:linClrLst meth="repeat">
+      <a:schemeClr val="accent3"/>
+    </dgm:linClrLst>
+    <dgm:effectClrLst/>
+    <dgm:txLinClrLst/>
+    <dgm:txFillClrLst meth="repeat">
+      <a:schemeClr val="lt1"/>
+    </dgm:txFillClrLst>
+    <dgm:txEffectClrLst/>
+  </dgm:styleLbl>
+  <dgm:styleLbl name="parChTrans2D3">
+    <dgm:fillClrLst meth="repeat">
+      <a:schemeClr val="accent3"/>
+    </dgm:fillClrLst>
+    <dgm:linClrLst meth="repeat">
+      <a:schemeClr val="accent3"/>
+    </dgm:linClrLst>
+    <dgm:effectClrLst/>
+    <dgm:txLinClrLst/>
+    <dgm:txFillClrLst meth="repeat">
+      <a:schemeClr val="lt1"/>
+    </dgm:txFillClrLst>
+    <dgm:txEffectClrLst/>
+  </dgm:styleLbl>
+  <dgm:styleLbl name="parChTrans2D4">
+    <dgm:fillClrLst meth="repeat">
+      <a:schemeClr val="accent3"/>
+    </dgm:fillClrLst>
+    <dgm:linClrLst meth="repeat">
+      <a:schemeClr val="accent3"/>
+    </dgm:linClrLst>
+    <dgm:effectClrLst/>
+    <dgm:txLinClrLst/>
+    <dgm:txFillClrLst meth="repeat">
+      <a:schemeClr val="lt1"/>
+    </dgm:txFillClrLst>
+    <dgm:txEffectClrLst/>
+  </dgm:styleLbl>
   <dgm:styleLbl name="parChTrans1D1">
     <dgm:fillClrLst meth="repeat">
-      <a:schemeClr val="accent2"/>
+      <a:schemeClr val="accent3"/>
     </dgm:fillClrLst>
     <dgm:linClrLst meth="repeat">
-      <a:schemeClr val="accent1"/>
+      <a:schemeClr val="accent3">
+        <a:shade val="60000"/>
+      </a:schemeClr>
     </dgm:linClrLst>
     <dgm:effectClrLst/>
     <dgm:txLinClrLst/>
@@ -1478,12 +1434,12 @@
   </dgm:styleLbl>
   <dgm:styleLbl name="parChTrans1D2">
     <dgm:fillClrLst meth="repeat">
-      <a:schemeClr val="accent3">
-        <a:tint val="90000"/>
-      </a:schemeClr>
+      <a:schemeClr val="accent3"/>
     </dgm:fillClrLst>
     <dgm:linClrLst meth="repeat">
-      <a:schemeClr val="accent2"/>
+      <a:schemeClr val="accent3">
+        <a:shade val="60000"/>
+      </a:schemeClr>
     </dgm:linClrLst>
     <dgm:effectClrLst/>
     <dgm:txLinClrLst/>
@@ -1494,8 +1450,40 @@
   </dgm:styleLbl>
   <dgm:styleLbl name="parChTrans1D3">
     <dgm:fillClrLst meth="repeat">
-      <a:schemeClr val="accent4">
-        <a:tint val="70000"/>
+      <a:schemeClr val="accent3"/>
+    </dgm:fillClrLst>
+    <dgm:linClrLst meth="repeat">
+      <a:schemeClr val="accent3">
+        <a:shade val="80000"/>
+      </a:schemeClr>
+    </dgm:linClrLst>
+    <dgm:effectClrLst/>
+    <dgm:txLinClrLst/>
+    <dgm:txFillClrLst meth="repeat">
+      <a:schemeClr val="tx1"/>
+    </dgm:txFillClrLst>
+    <dgm:txEffectClrLst/>
+  </dgm:styleLbl>
+  <dgm:styleLbl name="parChTrans1D4">
+    <dgm:fillClrLst meth="repeat">
+      <a:schemeClr val="accent3"/>
+    </dgm:fillClrLst>
+    <dgm:linClrLst meth="repeat">
+      <a:schemeClr val="accent3">
+        <a:shade val="80000"/>
+      </a:schemeClr>
+    </dgm:linClrLst>
+    <dgm:effectClrLst/>
+    <dgm:txLinClrLst/>
+    <dgm:txFillClrLst meth="repeat">
+      <a:schemeClr val="tx1"/>
+    </dgm:txFillClrLst>
+    <dgm:txEffectClrLst/>
+  </dgm:styleLbl>
+  <dgm:styleLbl name="fgAcc1">
+    <dgm:fillClrLst meth="repeat">
+      <a:schemeClr val="lt1">
+        <a:alpha val="90000"/>
       </a:schemeClr>
     </dgm:fillClrLst>
     <dgm:linClrLst meth="repeat">
@@ -1504,38 +1492,18 @@
     <dgm:effectClrLst/>
     <dgm:txLinClrLst/>
     <dgm:txFillClrLst meth="repeat">
-      <a:schemeClr val="tx1"/>
+      <a:schemeClr val="dk1"/>
     </dgm:txFillClrLst>
     <dgm:txEffectClrLst/>
   </dgm:styleLbl>
-  <dgm:styleLbl name="parChTrans1D4">
-    <dgm:fillClrLst meth="repeat">
-      <a:schemeClr val="accent5">
-        <a:tint val="50000"/>
-      </a:schemeClr>
-    </dgm:fillClrLst>
-    <dgm:linClrLst meth="repeat">
-      <a:schemeClr val="accent4"/>
-    </dgm:linClrLst>
-    <dgm:effectClrLst/>
-    <dgm:txLinClrLst/>
-    <dgm:txFillClrLst meth="repeat">
-      <a:schemeClr val="tx1"/>
-    </dgm:txFillClrLst>
-    <dgm:txEffectClrLst/>
-  </dgm:styleLbl>
-  <dgm:styleLbl name="fgAcc1">
+  <dgm:styleLbl name="conFgAcc1">
     <dgm:fillClrLst meth="repeat">
       <a:schemeClr val="lt1">
         <a:alpha val="90000"/>
       </a:schemeClr>
     </dgm:fillClrLst>
     <dgm:linClrLst meth="repeat">
-      <a:schemeClr val="accent2"/>
       <a:schemeClr val="accent3"/>
-      <a:schemeClr val="accent4"/>
-      <a:schemeClr val="accent5"/>
-      <a:schemeClr val="accent6"/>
     </dgm:linClrLst>
     <dgm:effectClrLst/>
     <dgm:txLinClrLst/>
@@ -1544,18 +1512,14 @@
     </dgm:txFillClrLst>
     <dgm:txEffectClrLst/>
   </dgm:styleLbl>
-  <dgm:styleLbl name="conFgAcc1">
+  <dgm:styleLbl name="alignAcc1">
     <dgm:fillClrLst meth="repeat">
       <a:schemeClr val="lt1">
         <a:alpha val="90000"/>
       </a:schemeClr>
     </dgm:fillClrLst>
     <dgm:linClrLst meth="repeat">
-      <a:schemeClr val="accent2"/>
       <a:schemeClr val="accent3"/>
-      <a:schemeClr val="accent4"/>
-      <a:schemeClr val="accent5"/>
-      <a:schemeClr val="accent6"/>
     </dgm:linClrLst>
     <dgm:effectClrLst/>
     <dgm:txLinClrLst/>
@@ -1564,18 +1528,14 @@
     </dgm:txFillClrLst>
     <dgm:txEffectClrLst/>
   </dgm:styleLbl>
-  <dgm:styleLbl name="alignAcc1">
+  <dgm:styleLbl name="trAlignAcc1">
     <dgm:fillClrLst meth="repeat">
       <a:schemeClr val="lt1">
-        <a:alpha val="90000"/>
+        <a:alpha val="40000"/>
       </a:schemeClr>
     </dgm:fillClrLst>
     <dgm:linClrLst meth="repeat">
-      <a:schemeClr val="accent2"/>
       <a:schemeClr val="accent3"/>
-      <a:schemeClr val="accent4"/>
-      <a:schemeClr val="accent5"/>
-      <a:schemeClr val="accent6"/>
     </dgm:linClrLst>
     <dgm:effectClrLst/>
     <dgm:txLinClrLst/>
@@ -1584,14 +1544,14 @@
     </dgm:txFillClrLst>
     <dgm:txEffectClrLst/>
   </dgm:styleLbl>
-  <dgm:styleLbl name="trAlignAcc1">
+  <dgm:styleLbl name="bgAcc1">
     <dgm:fillClrLst meth="repeat">
       <a:schemeClr val="lt1">
-        <a:alpha val="40000"/>
+        <a:alpha val="90000"/>
       </a:schemeClr>
     </dgm:fillClrLst>
     <dgm:linClrLst meth="repeat">
-      <a:schemeClr val="accent1"/>
+      <a:schemeClr val="accent3"/>
     </dgm:linClrLst>
     <dgm:effectClrLst/>
     <dgm:txLinClrLst/>
@@ -1600,18 +1560,12 @@
     </dgm:txFillClrLst>
     <dgm:txEffectClrLst/>
   </dgm:styleLbl>
-  <dgm:styleLbl name="bgAcc1">
+  <dgm:styleLbl name="solidFgAcc1">
     <dgm:fillClrLst meth="repeat">
-      <a:schemeClr val="lt1">
-        <a:alpha val="90000"/>
-      </a:schemeClr>
+      <a:schemeClr val="lt1"/>
     </dgm:fillClrLst>
     <dgm:linClrLst meth="repeat">
-      <a:schemeClr val="accent2"/>
       <a:schemeClr val="accent3"/>
-      <a:schemeClr val="accent4"/>
-      <a:schemeClr val="accent5"/>
-      <a:schemeClr val="accent6"/>
     </dgm:linClrLst>
     <dgm:effectClrLst/>
     <dgm:txLinClrLst/>
@@ -1620,16 +1574,12 @@
     </dgm:txFillClrLst>
     <dgm:txEffectClrLst/>
   </dgm:styleLbl>
-  <dgm:styleLbl name="solidFgAcc1">
+  <dgm:styleLbl name="solidAlignAcc1">
     <dgm:fillClrLst meth="repeat">
       <a:schemeClr val="lt1"/>
     </dgm:fillClrLst>
     <dgm:linClrLst meth="repeat">
-      <a:schemeClr val="accent2"/>
       <a:schemeClr val="accent3"/>
-      <a:schemeClr val="accent4"/>
-      <a:schemeClr val="accent5"/>
-      <a:schemeClr val="accent6"/>
     </dgm:linClrLst>
     <dgm:effectClrLst/>
     <dgm:txLinClrLst/>
@@ -1638,16 +1588,12 @@
     </dgm:txFillClrLst>
     <dgm:txEffectClrLst/>
   </dgm:styleLbl>
-  <dgm:styleLbl name="solidAlignAcc1">
+  <dgm:styleLbl name="solidBgAcc1">
     <dgm:fillClrLst meth="repeat">
       <a:schemeClr val="lt1"/>
     </dgm:fillClrLst>
     <dgm:linClrLst meth="repeat">
-      <a:schemeClr val="accent2"/>
       <a:schemeClr val="accent3"/>
-      <a:schemeClr val="accent4"/>
-      <a:schemeClr val="accent5"/>
-      <a:schemeClr val="accent6"/>
     </dgm:linClrLst>
     <dgm:effectClrLst/>
     <dgm:txLinClrLst/>
@@ -1656,67 +1602,17 @@
     </dgm:txFillClrLst>
     <dgm:txEffectClrLst/>
   </dgm:styleLbl>
-  <dgm:styleLbl name="solidBgAcc1">
-    <dgm:fillClrLst meth="repeat">
-      <a:schemeClr val="lt1"/>
-    </dgm:fillClrLst>
-    <dgm:linClrLst meth="repeat">
-      <a:schemeClr val="accent2"/>
-      <a:schemeClr val="accent3"/>
-      <a:schemeClr val="accent4"/>
-      <a:schemeClr val="accent5"/>
-      <a:schemeClr val="accent6"/>
-    </dgm:linClrLst>
-    <dgm:effectClrLst/>
-    <dgm:txLinClrLst/>
-    <dgm:txFillClrLst meth="repeat">
-      <a:schemeClr val="dk1"/>
-    </dgm:txFillClrLst>
-    <dgm:txEffectClrLst/>
-  </dgm:styleLbl>
   <dgm:styleLbl name="fgAccFollowNode1">
     <dgm:fillClrLst meth="repeat">
-      <a:schemeClr val="accent2">
+      <a:schemeClr val="accent3">
+        <a:alpha val="90000"/>
         <a:tint val="40000"/>
-        <a:alpha val="90000"/>
-      </a:schemeClr>
-      <a:schemeClr val="accent3">
-        <a:tint val="40000"/>
-        <a:alpha val="90000"/>
-      </a:schemeClr>
-      <a:schemeClr val="accent4">
-        <a:tint val="40000"/>
-        <a:alpha val="90000"/>
-      </a:schemeClr>
-      <a:schemeClr val="accent5">
-        <a:tint val="40000"/>
-        <a:alpha val="90000"/>
-      </a:schemeClr>
-      <a:schemeClr val="accent6">
-        <a:tint val="40000"/>
-        <a:alpha val="90000"/>
       </a:schemeClr>
     </dgm:fillClrLst>
     <dgm:linClrLst meth="repeat">
-      <a:schemeClr val="accent2">
+      <a:schemeClr val="accent3">
+        <a:alpha val="90000"/>
         <a:tint val="40000"/>
-        <a:alpha val="90000"/>
-      </a:schemeClr>
-      <a:schemeClr val="accent3">
-        <a:tint val="40000"/>
-        <a:alpha val="90000"/>
-      </a:schemeClr>
-      <a:schemeClr val="accent4">
-        <a:tint val="40000"/>
-        <a:alpha val="90000"/>
-      </a:schemeClr>
-      <a:schemeClr val="accent5">
-        <a:tint val="40000"/>
-        <a:alpha val="90000"/>
-      </a:schemeClr>
-      <a:schemeClr val="accent6">
-        <a:tint val="40000"/>
-        <a:alpha val="90000"/>
       </a:schemeClr>
     </dgm:linClrLst>
     <dgm:effectClrLst/>
@@ -1728,47 +1624,15 @@
   </dgm:styleLbl>
   <dgm:styleLbl name="alignAccFollowNode1">
     <dgm:fillClrLst meth="repeat">
-      <a:schemeClr val="accent2">
+      <a:schemeClr val="accent3">
+        <a:alpha val="90000"/>
         <a:tint val="40000"/>
-        <a:alpha val="90000"/>
-      </a:schemeClr>
-      <a:schemeClr val="accent3">
-        <a:tint val="40000"/>
-        <a:alpha val="90000"/>
-      </a:schemeClr>
-      <a:schemeClr val="accent4">
-        <a:tint val="40000"/>
-        <a:alpha val="90000"/>
-      </a:schemeClr>
-      <a:schemeClr val="accent5">
-        <a:tint val="40000"/>
-        <a:alpha val="90000"/>
-      </a:schemeClr>
-      <a:schemeClr val="accent6">
-        <a:tint val="40000"/>
-        <a:alpha val="90000"/>
       </a:schemeClr>
     </dgm:fillClrLst>
     <dgm:linClrLst meth="repeat">
-      <a:schemeClr val="accent2">
+      <a:schemeClr val="accent3">
+        <a:alpha val="90000"/>
         <a:tint val="40000"/>
-        <a:alpha val="90000"/>
-      </a:schemeClr>
-      <a:schemeClr val="accent3">
-        <a:tint val="40000"/>
-        <a:alpha val="90000"/>
-      </a:schemeClr>
-      <a:schemeClr val="accent4">
-        <a:tint val="40000"/>
-        <a:alpha val="90000"/>
-      </a:schemeClr>
-      <a:schemeClr val="accent5">
-        <a:tint val="40000"/>
-        <a:alpha val="90000"/>
-      </a:schemeClr>
-      <a:schemeClr val="accent6">
-        <a:tint val="40000"/>
-        <a:alpha val="90000"/>
       </a:schemeClr>
     </dgm:linClrLst>
     <dgm:effectClrLst/>
@@ -1780,47 +1644,15 @@
   </dgm:styleLbl>
   <dgm:styleLbl name="bgAccFollowNode1">
     <dgm:fillClrLst meth="repeat">
-      <a:schemeClr val="accent2">
+      <a:schemeClr val="accent3">
+        <a:alpha val="90000"/>
         <a:tint val="40000"/>
-        <a:alpha val="90000"/>
-      </a:schemeClr>
-      <a:schemeClr val="accent3">
-        <a:tint val="40000"/>
-        <a:alpha val="90000"/>
-      </a:schemeClr>
-      <a:schemeClr val="accent4">
-        <a:tint val="40000"/>
-        <a:alpha val="90000"/>
-      </a:schemeClr>
-      <a:schemeClr val="accent5">
-        <a:tint val="40000"/>
-        <a:alpha val="90000"/>
-      </a:schemeClr>
-      <a:schemeClr val="accent6">
-        <a:tint val="40000"/>
-        <a:alpha val="90000"/>
       </a:schemeClr>
     </dgm:fillClrLst>
     <dgm:linClrLst meth="repeat">
-      <a:schemeClr val="accent2">
+      <a:schemeClr val="accent3">
+        <a:alpha val="90000"/>
         <a:tint val="40000"/>
-        <a:alpha val="90000"/>
-      </a:schemeClr>
-      <a:schemeClr val="accent3">
-        <a:tint val="40000"/>
-        <a:alpha val="90000"/>
-      </a:schemeClr>
-      <a:schemeClr val="accent4">
-        <a:tint val="40000"/>
-        <a:alpha val="90000"/>
-      </a:schemeClr>
-      <a:schemeClr val="accent5">
-        <a:tint val="40000"/>
-        <a:alpha val="90000"/>
-      </a:schemeClr>
-      <a:schemeClr val="accent6">
-        <a:tint val="40000"/>
-        <a:alpha val="90000"/>
       </a:schemeClr>
     </dgm:linClrLst>
     <dgm:effectClrLst/>
@@ -1836,39 +1668,7 @@
         <a:alpha val="90000"/>
       </a:schemeClr>
     </dgm:fillClrLst>
-    <dgm:linClrLst>
-      <a:schemeClr val="accent1"/>
-    </dgm:linClrLst>
-    <dgm:effectClrLst/>
-    <dgm:txLinClrLst/>
-    <dgm:txFillClrLst meth="repeat">
-      <a:schemeClr val="dk1"/>
-    </dgm:txFillClrLst>
-    <dgm:txEffectClrLst/>
-  </dgm:styleLbl>
-  <dgm:styleLbl name="fgAcc2">
-    <dgm:fillClrLst meth="repeat">
-      <a:schemeClr val="lt1">
-        <a:alpha val="90000"/>
-      </a:schemeClr>
-    </dgm:fillClrLst>
-    <dgm:linClrLst>
-      <a:schemeClr val="accent2"/>
-    </dgm:linClrLst>
-    <dgm:effectClrLst/>
-    <dgm:txLinClrLst/>
-    <dgm:txFillClrLst meth="repeat">
-      <a:schemeClr val="dk1"/>
-    </dgm:txFillClrLst>
-    <dgm:txEffectClrLst/>
-  </dgm:styleLbl>
-  <dgm:styleLbl name="fgAcc3">
-    <dgm:fillClrLst meth="repeat">
-      <a:schemeClr val="lt1">
-        <a:alpha val="90000"/>
-      </a:schemeClr>
-    </dgm:fillClrLst>
-    <dgm:linClrLst>
+    <dgm:linClrLst meth="repeat">
       <a:schemeClr val="accent3"/>
     </dgm:linClrLst>
     <dgm:effectClrLst/>
@@ -1878,14 +1678,14 @@
     </dgm:txFillClrLst>
     <dgm:txEffectClrLst/>
   </dgm:styleLbl>
-  <dgm:styleLbl name="fgAcc4">
+  <dgm:styleLbl name="fgAcc2">
     <dgm:fillClrLst meth="repeat">
       <a:schemeClr val="lt1">
         <a:alpha val="90000"/>
       </a:schemeClr>
     </dgm:fillClrLst>
-    <dgm:linClrLst>
-      <a:schemeClr val="accent4"/>
+    <dgm:linClrLst meth="repeat">
+      <a:schemeClr val="accent3"/>
     </dgm:linClrLst>
     <dgm:effectClrLst/>
     <dgm:txLinClrLst/>
@@ -1894,13 +1694,41 @@
     </dgm:txFillClrLst>
     <dgm:txEffectClrLst/>
   </dgm:styleLbl>
+  <dgm:styleLbl name="fgAcc3">
+    <dgm:fillClrLst meth="repeat">
+      <a:schemeClr val="lt1">
+        <a:alpha val="90000"/>
+      </a:schemeClr>
+    </dgm:fillClrLst>
+    <dgm:linClrLst meth="repeat">
+      <a:schemeClr val="accent3"/>
+    </dgm:linClrLst>
+    <dgm:effectClrLst/>
+    <dgm:txLinClrLst/>
+    <dgm:txFillClrLst meth="repeat">
+      <a:schemeClr val="dk1"/>
+    </dgm:txFillClrLst>
+    <dgm:txEffectClrLst/>
+  </dgm:styleLbl>
+  <dgm:styleLbl name="fgAcc4">
+    <dgm:fillClrLst meth="repeat">
+      <a:schemeClr val="lt1">
+        <a:alpha val="90000"/>
+      </a:schemeClr>
+    </dgm:fillClrLst>
+    <dgm:linClrLst meth="repeat">
+      <a:schemeClr val="accent3"/>
+    </dgm:linClrLst>
+    <dgm:effectClrLst/>
+    <dgm:txLinClrLst/>
+    <dgm:txFillClrLst meth="repeat">
+      <a:schemeClr val="dk1"/>
+    </dgm:txFillClrLst>
+    <dgm:txEffectClrLst/>
+  </dgm:styleLbl>
   <dgm:styleLbl name="bgShp">
     <dgm:fillClrLst meth="repeat">
-      <a:schemeClr val="accent2"/>
       <a:schemeClr val="accent3"/>
-      <a:schemeClr val="accent4"/>
-      <a:schemeClr val="accent5"/>
-      <a:schemeClr val="accent6"/>
     </dgm:fillClrLst>
     <dgm:linClrLst meth="repeat">
       <a:schemeClr val="lt1">
@@ -1914,12 +1742,12 @@
   </dgm:styleLbl>
   <dgm:styleLbl name="dkBgShp">
     <dgm:fillClrLst meth="repeat">
-      <a:schemeClr val="accent2">
-        <a:shade val="90000"/>
+      <a:schemeClr val="accent3">
+        <a:shade val="80000"/>
       </a:schemeClr>
     </dgm:fillClrLst>
     <dgm:linClrLst meth="repeat">
-      <a:schemeClr val="dk1"/>
+      <a:schemeClr val="accent3"/>
     </dgm:linClrLst>
     <dgm:effectClrLst/>
     <dgm:txLinClrLst/>
@@ -1930,13 +1758,13 @@
   </dgm:styleLbl>
   <dgm:styleLbl name="trBgShp">
     <dgm:fillClrLst meth="repeat">
-      <a:schemeClr val="accent1">
+      <a:schemeClr val="accent3">
         <a:tint val="50000"/>
         <a:alpha val="40000"/>
       </a:schemeClr>
     </dgm:fillClrLst>
     <dgm:linClrLst meth="repeat">
-      <a:schemeClr val="accent2"/>
+      <a:schemeClr val="accent3"/>
     </dgm:linClrLst>
     <dgm:effectClrLst/>
     <dgm:txLinClrLst/>
@@ -1947,8 +1775,8 @@
   </dgm:styleLbl>
   <dgm:styleLbl name="fgShp">
     <dgm:fillClrLst meth="repeat">
-      <a:schemeClr val="accent2">
-        <a:tint val="40000"/>
+      <a:schemeClr val="accent3">
+        <a:tint val="60000"/>
       </a:schemeClr>
     </dgm:fillClrLst>
     <dgm:linClrLst meth="repeat">
@@ -4053,7 +3881,7 @@
 <dgm:dataModel xmlns:dgm="http://schemas.openxmlformats.org/drawingml/2006/diagram" xmlns:a="http://schemas.openxmlformats.org/drawingml/2006/main">
   <dgm:ptLst>
     <dgm:pt modelId="{D84AB7F7-798C-4CE5-B049-829884D6DC68}" type="doc">
-      <dgm:prSet loTypeId="urn:microsoft.com/office/officeart/2018/2/layout/IconCircleList" loCatId="icon" qsTypeId="urn:microsoft.com/office/officeart/2005/8/quickstyle/simple1" qsCatId="simple" csTypeId="urn:microsoft.com/office/officeart/2018/5/colors/Iconchunking_neutralicon_colorful1" csCatId="colorful" phldr="1"/>
+      <dgm:prSet loTypeId="urn:microsoft.com/office/officeart/2018/2/layout/IconCircleList" loCatId="icon" qsTypeId="urn:microsoft.com/office/officeart/2005/8/quickstyle/simple1" qsCatId="simple" csTypeId="urn:microsoft.com/office/officeart/2018/5/colors/Iconchunking_neutralicon_accent3_2" csCatId="accent3" phldr="1"/>
       <dgm:spPr/>
       <dgm:t>
         <a:bodyPr/>
@@ -4594,11 +4422,13 @@
     <dgm:cxn modelId="{52FD72B3-0E5E-4EF9-8C23-D787CF247A4D}" type="presParOf" srcId="{BDD142D7-BEC2-476B-9DF1-431331483E97}" destId="{6518EE04-33E8-46F9-974C-EA2724D07BDF}" srcOrd="2" destOrd="0" presId="urn:microsoft.com/office/officeart/2018/2/layout/IconCircleList"/>
     <dgm:cxn modelId="{16ED4207-8D5B-40FC-B888-D9BC246B2385}" type="presParOf" srcId="{BDD142D7-BEC2-476B-9DF1-431331483E97}" destId="{030AAEC7-59DB-4A11-B48B-1893EEF80F12}" srcOrd="3" destOrd="0" presId="urn:microsoft.com/office/officeart/2018/2/layout/IconCircleList"/>
   </dgm:cxnLst>
-  <dgm:bg/>
+  <dgm:bg>
+    <a:noFill/>
+  </dgm:bg>
   <dgm:whole/>
   <dgm:extLst>
     <a:ext uri="http://schemas.microsoft.com/office/drawing/2008/diagram">
-      <dsp:dataModelExt xmlns:dsp="http://schemas.microsoft.com/office/drawing/2008/diagram" relId="rId6" minVer="http://schemas.openxmlformats.org/drawingml/2006/diagram"/>
+      <dsp:dataModelExt xmlns:dsp="http://schemas.microsoft.com/office/drawing/2008/diagram" relId="rId8" minVer="http://schemas.openxmlformats.org/drawingml/2006/diagram"/>
     </a:ext>
   </dgm:extLst>
 </dgm:dataModel>
@@ -5968,14 +5798,14 @@
       </dsp:nvSpPr>
       <dsp:spPr>
         <a:xfrm>
-          <a:off x="616935" y="1100"/>
-          <a:ext cx="921683" cy="921683"/>
+          <a:off x="219245" y="426"/>
+          <a:ext cx="579403" cy="579403"/>
         </a:xfrm>
         <a:prstGeom prst="ellipse">
           <a:avLst/>
         </a:prstGeom>
         <a:solidFill>
-          <a:schemeClr val="accent2">
+          <a:schemeClr val="accent3">
             <a:hueOff val="0"/>
             <a:satOff val="0"/>
             <a:lumOff val="0"/>
@@ -6007,8 +5837,8 @@
       </dsp:nvSpPr>
       <dsp:spPr>
         <a:xfrm>
-          <a:off x="810488" y="194654"/>
-          <a:ext cx="534576" cy="534576"/>
+          <a:off x="340920" y="122101"/>
+          <a:ext cx="336053" cy="336053"/>
         </a:xfrm>
         <a:prstGeom prst="rect">
           <a:avLst/>
@@ -6057,8 +5887,8 @@
       </dsp:nvSpPr>
       <dsp:spPr>
         <a:xfrm>
-          <a:off x="1736122" y="1100"/>
-          <a:ext cx="2172539" cy="921683"/>
+          <a:off x="922806" y="426"/>
+          <a:ext cx="1365735" cy="579403"/>
         </a:xfrm>
         <a:prstGeom prst="rect">
           <a:avLst/>
@@ -6087,7 +5917,7 @@
         </a:bodyPr>
         <a:lstStyle/>
         <a:p>
-          <a:pPr marL="0" lvl="0" indent="0" algn="l" defTabSz="711200">
+          <a:pPr marL="0" lvl="0" indent="0" algn="l" defTabSz="488950">
             <a:lnSpc>
               <a:spcPct val="90000"/>
             </a:lnSpc>
@@ -6100,30 +5930,30 @@
             <a:buNone/>
           </a:pPr>
           <a:r>
-            <a:rPr lang="es-EC" sz="1600" kern="1200" noProof="0" dirty="0"/>
+            <a:rPr lang="es-EC" sz="1100" kern="1200" noProof="0" dirty="0"/>
             <a:t>Fuente: Repositorio público de </a:t>
           </a:r>
           <a:r>
-            <a:rPr lang="es-EC" sz="1600" kern="1200" noProof="0" dirty="0" err="1"/>
+            <a:rPr lang="es-EC" sz="1100" kern="1200" noProof="0" dirty="0" err="1"/>
             <a:t>Titanic</a:t>
           </a:r>
           <a:r>
-            <a:rPr lang="es-EC" sz="1600" kern="1200" noProof="0" dirty="0"/>
+            <a:rPr lang="es-EC" sz="1100" kern="1200" noProof="0" dirty="0"/>
             <a:t> (</a:t>
           </a:r>
           <a:r>
-            <a:rPr lang="es-EC" sz="1600" kern="1200" noProof="0" dirty="0" err="1"/>
+            <a:rPr lang="es-EC" sz="1100" kern="1200" noProof="0" dirty="0" err="1"/>
             <a:t>Kaggle</a:t>
           </a:r>
           <a:r>
-            <a:rPr lang="es-EC" sz="1600" kern="1200" noProof="0" dirty="0"/>
+            <a:rPr lang="es-EC" sz="1100" kern="1200" noProof="0" dirty="0"/>
             <a:t>)</a:t>
           </a:r>
         </a:p>
       </dsp:txBody>
       <dsp:txXfrm>
-        <a:off x="1736122" y="1100"/>
-        <a:ext cx="2172539" cy="921683"/>
+        <a:off x="922806" y="426"/>
+        <a:ext cx="1365735" cy="579403"/>
       </dsp:txXfrm>
     </dsp:sp>
     <dsp:sp modelId="{D23C5D47-B3AA-4706-9B15-83F889B4F134}">
@@ -6133,8 +5963,8 @@
       </dsp:nvSpPr>
       <dsp:spPr>
         <a:xfrm>
-          <a:off x="4287209" y="1100"/>
-          <a:ext cx="921683" cy="921683"/>
+          <a:off x="2526511" y="426"/>
+          <a:ext cx="579403" cy="579403"/>
         </a:xfrm>
         <a:prstGeom prst="ellipse">
           <a:avLst/>
@@ -6172,8 +6002,8 @@
       </dsp:nvSpPr>
       <dsp:spPr>
         <a:xfrm>
-          <a:off x="4480763" y="194654"/>
-          <a:ext cx="534576" cy="534576"/>
+          <a:off x="2648186" y="122101"/>
+          <a:ext cx="336053" cy="336053"/>
         </a:xfrm>
         <a:prstGeom prst="rect">
           <a:avLst/>
@@ -6222,8 +6052,8 @@
       </dsp:nvSpPr>
       <dsp:spPr>
         <a:xfrm>
-          <a:off x="5406396" y="1100"/>
-          <a:ext cx="2172539" cy="921683"/>
+          <a:off x="3230072" y="426"/>
+          <a:ext cx="1365735" cy="579403"/>
         </a:xfrm>
         <a:prstGeom prst="rect">
           <a:avLst/>
@@ -6252,7 +6082,7 @@
         </a:bodyPr>
         <a:lstStyle/>
         <a:p>
-          <a:pPr marL="0" lvl="0" indent="0" algn="l" defTabSz="711200">
+          <a:pPr marL="0" lvl="0" indent="0" algn="l" defTabSz="488950">
             <a:lnSpc>
               <a:spcPct val="90000"/>
             </a:lnSpc>
@@ -6265,14 +6095,14 @@
             <a:buNone/>
           </a:pPr>
           <a:r>
-            <a:rPr lang="es-EC" sz="1600" kern="1200" noProof="0" dirty="0"/>
+            <a:rPr lang="es-EC" sz="1100" kern="1200" noProof="0" dirty="0"/>
             <a:t>Observaciones: 891</a:t>
           </a:r>
         </a:p>
       </dsp:txBody>
       <dsp:txXfrm>
-        <a:off x="5406396" y="1100"/>
-        <a:ext cx="2172539" cy="921683"/>
+        <a:off x="3230072" y="426"/>
+        <a:ext cx="1365735" cy="579403"/>
       </dsp:txXfrm>
     </dsp:sp>
     <dsp:sp modelId="{310E65B9-C428-4C50-BF2A-00F7DF008AA5}">
@@ -6282,14 +6112,14 @@
       </dsp:nvSpPr>
       <dsp:spPr>
         <a:xfrm>
-          <a:off x="616935" y="1635560"/>
-          <a:ext cx="921683" cy="921683"/>
+          <a:off x="4833777" y="426"/>
+          <a:ext cx="579403" cy="579403"/>
         </a:xfrm>
         <a:prstGeom prst="ellipse">
           <a:avLst/>
         </a:prstGeom>
         <a:solidFill>
-          <a:schemeClr val="accent4">
+          <a:schemeClr val="accent3">
             <a:hueOff val="0"/>
             <a:satOff val="0"/>
             <a:lumOff val="0"/>
@@ -6321,8 +6151,8 @@
       </dsp:nvSpPr>
       <dsp:spPr>
         <a:xfrm>
-          <a:off x="810488" y="1829114"/>
-          <a:ext cx="534576" cy="534576"/>
+          <a:off x="4955452" y="122101"/>
+          <a:ext cx="336053" cy="336053"/>
         </a:xfrm>
         <a:prstGeom prst="rect">
           <a:avLst/>
@@ -6371,8 +6201,8 @@
       </dsp:nvSpPr>
       <dsp:spPr>
         <a:xfrm>
-          <a:off x="1736122" y="1635560"/>
-          <a:ext cx="2172539" cy="921683"/>
+          <a:off x="5537338" y="426"/>
+          <a:ext cx="1365735" cy="579403"/>
         </a:xfrm>
         <a:prstGeom prst="rect">
           <a:avLst/>
@@ -6401,7 +6231,7 @@
         </a:bodyPr>
         <a:lstStyle/>
         <a:p>
-          <a:pPr marL="0" lvl="0" indent="0" algn="l" defTabSz="711200">
+          <a:pPr marL="0" lvl="0" indent="0" algn="l" defTabSz="488950">
             <a:lnSpc>
               <a:spcPct val="90000"/>
             </a:lnSpc>
@@ -6414,14 +6244,14 @@
             <a:buNone/>
           </a:pPr>
           <a:r>
-            <a:rPr lang="es-EC" sz="1600" kern="1200" noProof="0" dirty="0"/>
+            <a:rPr lang="es-EC" sz="1100" kern="1200" noProof="0" dirty="0"/>
             <a:t>Variables: 12</a:t>
           </a:r>
         </a:p>
       </dsp:txBody>
       <dsp:txXfrm>
-        <a:off x="1736122" y="1635560"/>
-        <a:ext cx="2172539" cy="921683"/>
+        <a:off x="5537338" y="426"/>
+        <a:ext cx="1365735" cy="579403"/>
       </dsp:txXfrm>
     </dsp:sp>
     <dsp:sp modelId="{6F6C6AEF-B571-4D82-B572-0F88D45E9359}">
@@ -6431,14 +6261,14 @@
       </dsp:nvSpPr>
       <dsp:spPr>
         <a:xfrm>
-          <a:off x="4287209" y="1635560"/>
-          <a:ext cx="921683" cy="921683"/>
+          <a:off x="219245" y="805436"/>
+          <a:ext cx="579403" cy="579403"/>
         </a:xfrm>
         <a:prstGeom prst="ellipse">
           <a:avLst/>
         </a:prstGeom>
         <a:solidFill>
-          <a:schemeClr val="accent5">
+          <a:schemeClr val="accent3">
             <a:hueOff val="0"/>
             <a:satOff val="0"/>
             <a:lumOff val="0"/>
@@ -6470,8 +6300,8 @@
       </dsp:nvSpPr>
       <dsp:spPr>
         <a:xfrm>
-          <a:off x="4480763" y="1829114"/>
-          <a:ext cx="534576" cy="534576"/>
+          <a:off x="340920" y="927110"/>
+          <a:ext cx="336053" cy="336053"/>
         </a:xfrm>
         <a:prstGeom prst="rect">
           <a:avLst/>
@@ -6520,8 +6350,8 @@
       </dsp:nvSpPr>
       <dsp:spPr>
         <a:xfrm>
-          <a:off x="5406396" y="1635560"/>
-          <a:ext cx="2172539" cy="921683"/>
+          <a:off x="922806" y="805436"/>
+          <a:ext cx="1365735" cy="579403"/>
         </a:xfrm>
         <a:prstGeom prst="rect">
           <a:avLst/>
@@ -6550,7 +6380,7 @@
         </a:bodyPr>
         <a:lstStyle/>
         <a:p>
-          <a:pPr marL="0" lvl="0" indent="0" algn="l" defTabSz="711200">
+          <a:pPr marL="0" lvl="0" indent="0" algn="l" defTabSz="488950">
             <a:lnSpc>
               <a:spcPct val="90000"/>
             </a:lnSpc>
@@ -6563,22 +6393,22 @@
             <a:buNone/>
           </a:pPr>
           <a:r>
-            <a:rPr lang="es-EC" sz="1600" kern="1200" noProof="0" dirty="0"/>
+            <a:rPr lang="es-EC" sz="1100" kern="1200" noProof="0" dirty="0"/>
             <a:t>Variable objetivo Y: </a:t>
           </a:r>
           <a:r>
-            <a:rPr lang="es-EC" sz="1600" kern="1200" noProof="0" dirty="0" err="1"/>
+            <a:rPr lang="es-EC" sz="1100" kern="1200" noProof="0" dirty="0" err="1"/>
             <a:t>Survived</a:t>
           </a:r>
           <a:r>
-            <a:rPr lang="es-EC" sz="1600" kern="1200" noProof="0" dirty="0"/>
+            <a:rPr lang="es-EC" sz="1100" kern="1200" noProof="0" dirty="0"/>
             <a:t> (0 no sobrevivió, 1 sobrevivió)</a:t>
           </a:r>
         </a:p>
       </dsp:txBody>
       <dsp:txXfrm>
-        <a:off x="5406396" y="1635560"/>
-        <a:ext cx="2172539" cy="921683"/>
+        <a:off x="922806" y="805436"/>
+        <a:ext cx="1365735" cy="579403"/>
       </dsp:txXfrm>
     </dsp:sp>
     <dsp:sp modelId="{E14F2DC9-04B1-4A2F-A9B1-8A4A83E5BCE0}">
@@ -6588,14 +6418,14 @@
       </dsp:nvSpPr>
       <dsp:spPr>
         <a:xfrm>
-          <a:off x="616935" y="3270020"/>
-          <a:ext cx="921683" cy="921683"/>
+          <a:off x="2526511" y="805436"/>
+          <a:ext cx="579403" cy="579403"/>
         </a:xfrm>
         <a:prstGeom prst="ellipse">
           <a:avLst/>
         </a:prstGeom>
         <a:solidFill>
-          <a:schemeClr val="accent6">
+          <a:schemeClr val="accent3">
             <a:hueOff val="0"/>
             <a:satOff val="0"/>
             <a:lumOff val="0"/>
@@ -6627,8 +6457,8 @@
       </dsp:nvSpPr>
       <dsp:spPr>
         <a:xfrm>
-          <a:off x="810488" y="3463574"/>
-          <a:ext cx="534576" cy="534576"/>
+          <a:off x="2648186" y="927110"/>
+          <a:ext cx="336053" cy="336053"/>
         </a:xfrm>
         <a:prstGeom prst="rect">
           <a:avLst/>
@@ -6677,8 +6507,8 @@
       </dsp:nvSpPr>
       <dsp:spPr>
         <a:xfrm>
-          <a:off x="1736122" y="3270020"/>
-          <a:ext cx="2172539" cy="921683"/>
+          <a:off x="3230072" y="805436"/>
+          <a:ext cx="1365735" cy="579403"/>
         </a:xfrm>
         <a:prstGeom prst="rect">
           <a:avLst/>
@@ -6707,7 +6537,7 @@
         </a:bodyPr>
         <a:lstStyle/>
         <a:p>
-          <a:pPr marL="0" lvl="0" indent="0" algn="l" defTabSz="711200">
+          <a:pPr marL="0" lvl="0" indent="0" algn="l" defTabSz="488950">
             <a:lnSpc>
               <a:spcPct val="90000"/>
             </a:lnSpc>
@@ -6720,14 +6550,14 @@
             <a:buNone/>
           </a:pPr>
           <a:r>
-            <a:rPr lang="es-EC" sz="1600" kern="1200" noProof="0" dirty="0"/>
+            <a:rPr lang="es-EC" sz="1100" kern="1200" noProof="0" dirty="0"/>
             <a:t>Tasa global de supervivencia: 38.38%</a:t>
           </a:r>
         </a:p>
       </dsp:txBody>
       <dsp:txXfrm>
-        <a:off x="1736122" y="3270020"/>
-        <a:ext cx="2172539" cy="921683"/>
+        <a:off x="3230072" y="805436"/>
+        <a:ext cx="1365735" cy="579403"/>
       </dsp:txXfrm>
     </dsp:sp>
   </dsp:spTree>
@@ -13257,7 +13087,7 @@
           <a:p>
             <a:fld id="{5BCAD085-E8A6-8845-BD4E-CB4CCA059FC4}" type="datetimeFigureOut">
               <a:rPr lang="en-US" smtClean="0"/>
-              <a:t>4/17/2026</a:t>
+              <a:t>4/21/2026</a:t>
             </a:fld>
             <a:endParaRPr lang="en-US"/>
           </a:p>
@@ -13457,7 +13287,7 @@
           <a:p>
             <a:fld id="{5BCAD085-E8A6-8845-BD4E-CB4CCA059FC4}" type="datetimeFigureOut">
               <a:rPr lang="en-US" smtClean="0"/>
-              <a:t>4/17/2026</a:t>
+              <a:t>4/21/2026</a:t>
             </a:fld>
             <a:endParaRPr lang="en-US"/>
           </a:p>
@@ -13667,7 +13497,7 @@
           <a:p>
             <a:fld id="{5BCAD085-E8A6-8845-BD4E-CB4CCA059FC4}" type="datetimeFigureOut">
               <a:rPr lang="en-US" smtClean="0"/>
-              <a:t>4/17/2026</a:t>
+              <a:t>4/21/2026</a:t>
             </a:fld>
             <a:endParaRPr lang="en-US"/>
           </a:p>
@@ -13867,7 +13697,7 @@
           <a:p>
             <a:fld id="{5BCAD085-E8A6-8845-BD4E-CB4CCA059FC4}" type="datetimeFigureOut">
               <a:rPr lang="en-US" smtClean="0"/>
-              <a:t>4/17/2026</a:t>
+              <a:t>4/21/2026</a:t>
             </a:fld>
             <a:endParaRPr lang="en-US"/>
           </a:p>
@@ -14143,7 +13973,7 @@
           <a:p>
             <a:fld id="{5BCAD085-E8A6-8845-BD4E-CB4CCA059FC4}" type="datetimeFigureOut">
               <a:rPr lang="en-US" smtClean="0"/>
-              <a:t>4/17/2026</a:t>
+              <a:t>4/21/2026</a:t>
             </a:fld>
             <a:endParaRPr lang="en-US"/>
           </a:p>
@@ -14411,7 +14241,7 @@
           <a:p>
             <a:fld id="{5BCAD085-E8A6-8845-BD4E-CB4CCA059FC4}" type="datetimeFigureOut">
               <a:rPr lang="en-US" smtClean="0"/>
-              <a:t>4/17/2026</a:t>
+              <a:t>4/21/2026</a:t>
             </a:fld>
             <a:endParaRPr lang="en-US"/>
           </a:p>
@@ -14826,7 +14656,7 @@
           <a:p>
             <a:fld id="{5BCAD085-E8A6-8845-BD4E-CB4CCA059FC4}" type="datetimeFigureOut">
               <a:rPr lang="en-US" smtClean="0"/>
-              <a:t>4/17/2026</a:t>
+              <a:t>4/21/2026</a:t>
             </a:fld>
             <a:endParaRPr lang="en-US"/>
           </a:p>
@@ -14968,7 +14798,7 @@
           <a:p>
             <a:fld id="{5BCAD085-E8A6-8845-BD4E-CB4CCA059FC4}" type="datetimeFigureOut">
               <a:rPr lang="en-US" smtClean="0"/>
-              <a:t>4/17/2026</a:t>
+              <a:t>4/21/2026</a:t>
             </a:fld>
             <a:endParaRPr lang="en-US"/>
           </a:p>
@@ -15081,7 +14911,7 @@
           <a:p>
             <a:fld id="{5BCAD085-E8A6-8845-BD4E-CB4CCA059FC4}" type="datetimeFigureOut">
               <a:rPr lang="en-US" smtClean="0"/>
-              <a:t>4/17/2026</a:t>
+              <a:t>4/21/2026</a:t>
             </a:fld>
             <a:endParaRPr lang="en-US"/>
           </a:p>
@@ -15394,7 +15224,7 @@
           <a:p>
             <a:fld id="{5BCAD085-E8A6-8845-BD4E-CB4CCA059FC4}" type="datetimeFigureOut">
               <a:rPr lang="en-US" smtClean="0"/>
-              <a:t>4/17/2026</a:t>
+              <a:t>4/21/2026</a:t>
             </a:fld>
             <a:endParaRPr lang="en-US"/>
           </a:p>
@@ -15683,7 +15513,7 @@
           <a:p>
             <a:fld id="{5BCAD085-E8A6-8845-BD4E-CB4CCA059FC4}" type="datetimeFigureOut">
               <a:rPr lang="en-US" smtClean="0"/>
-              <a:t>4/17/2026</a:t>
+              <a:t>4/21/2026</a:t>
             </a:fld>
             <a:endParaRPr lang="en-US"/>
           </a:p>
@@ -15926,7 +15756,7 @@
           <a:p>
             <a:fld id="{5BCAD085-E8A6-8845-BD4E-CB4CCA059FC4}" type="datetimeFigureOut">
               <a:rPr lang="en-US" smtClean="0"/>
-              <a:t>4/17/2026</a:t>
+              <a:t>4/21/2026</a:t>
             </a:fld>
             <a:endParaRPr lang="en-US"/>
           </a:p>
@@ -16681,8 +16511,9 @@
             <a:r>
               <a:rPr lang="es-EC" sz="1500" b="1" noProof="0" dirty="0">
                 <a:solidFill>
-                  <a:schemeClr val="bg1">
-                    <a:lumMod val="50000"/>
+                  <a:schemeClr val="accent2">
+                    <a:lumMod val="60000"/>
+                    <a:lumOff val="40000"/>
                   </a:schemeClr>
                 </a:solidFill>
               </a:rPr>
@@ -16697,8 +16528,9 @@
             <a:r>
               <a:rPr lang="es-EC" sz="1500" b="1" noProof="0" dirty="0">
                 <a:solidFill>
-                  <a:schemeClr val="bg1">
-                    <a:lumMod val="50000"/>
+                  <a:schemeClr val="accent2">
+                    <a:lumMod val="60000"/>
+                    <a:lumOff val="40000"/>
                   </a:schemeClr>
                 </a:solidFill>
               </a:rPr>
@@ -16713,8 +16545,9 @@
             <a:r>
               <a:rPr lang="es-EC" sz="1500" b="1" noProof="0" dirty="0">
                 <a:solidFill>
-                  <a:schemeClr val="bg1">
-                    <a:lumMod val="50000"/>
+                  <a:schemeClr val="accent2">
+                    <a:lumMod val="60000"/>
+                    <a:lumOff val="40000"/>
                   </a:schemeClr>
                 </a:solidFill>
               </a:rPr>
@@ -17617,10 +17450,10 @@
       </p:grpSpPr>
       <p:sp useBgFill="1">
         <p:nvSpPr>
-          <p:cNvPr id="9" name="Rectangle 8">
+          <p:cNvPr id="30" name="Rectangle 19">
             <a:extLst>
               <a:ext uri="{FF2B5EF4-FFF2-40B4-BE49-F238E27FC236}">
-                <a16:creationId xmlns:a16="http://schemas.microsoft.com/office/drawing/2014/main" id="{BACC6370-2D7E-4714-9D71-7542949D7D5D}"/>
+                <a16:creationId xmlns:a16="http://schemas.microsoft.com/office/drawing/2014/main" id="{B712E947-0734-45F9-9C4F-41114EC3A33E}"/>
               </a:ext>
               <a:ext uri="{C183D7F6-B498-43B3-948B-1728B52AA6E4}">
                 <adec:decorative xmlns:adec="http://schemas.microsoft.com/office/drawing/2017/decorative" val="1"/>
@@ -17640,7 +17473,7 @@
         </p:nvSpPr>
         <p:spPr>
           <a:xfrm>
-            <a:off x="0" y="0"/>
+            <a:off x="10713" y="0"/>
             <a:ext cx="9144000" cy="6858000"/>
           </a:xfrm>
           <a:prstGeom prst="rect">
@@ -17687,25 +17520,25 @@
           <a:lstStyle/>
           <a:p>
             <a:pPr algn="ctr"/>
-            <a:endParaRPr lang="es-EC" noProof="0" dirty="0"/>
+            <a:endParaRPr lang="en-US"/>
           </a:p>
         </p:txBody>
       </p:sp>
-      <p:sp>
-        <p:nvSpPr>
-          <p:cNvPr id="11" name="Rectangle 10">
+      <p:grpSp>
+        <p:nvGrpSpPr>
+          <p:cNvPr id="31" name="Group 21">
             <a:extLst>
               <a:ext uri="{FF2B5EF4-FFF2-40B4-BE49-F238E27FC236}">
-                <a16:creationId xmlns:a16="http://schemas.microsoft.com/office/drawing/2014/main" id="{F68B3F68-107C-434F-AA38-110D5EA91B85}"/>
+                <a16:creationId xmlns:a16="http://schemas.microsoft.com/office/drawing/2014/main" id="{12B3290A-D3BF-4B87-B55B-FD9A98B49727}"/>
               </a:ext>
               <a:ext uri="{C183D7F6-B498-43B3-948B-1728B52AA6E4}">
                 <adec:decorative xmlns:adec="http://schemas.microsoft.com/office/drawing/2017/decorative" val="1"/>
               </a:ext>
             </a:extLst>
           </p:cNvPr>
-          <p:cNvSpPr>
-            <a:spLocks noGrp="1" noRot="1" noChangeAspect="1" noMove="1" noResize="1" noEditPoints="1" noAdjustHandles="1" noChangeArrowheads="1" noChangeShapeType="1" noTextEdit="1"/>
-          </p:cNvSpPr>
+          <p:cNvGrpSpPr>
+            <a:grpSpLocks noGrp="1" noUngrp="1" noRot="1" noChangeAspect="1" noMove="1" noResize="1"/>
+          </p:cNvGrpSpPr>
           <p:nvPr>
             <p:extLst>
               <p:ext uri="{386F3935-93C4-4BCD-93E2-E3B085C9AB24}">
@@ -17713,210 +17546,236 @@
               </p:ext>
             </p:extLst>
           </p:nvPr>
-        </p:nvSpPr>
-        <p:spPr>
-          <a:xfrm flipH="1">
-            <a:off x="1" y="0"/>
-            <a:ext cx="9143999" cy="1575955"/>
+        </p:nvGrpSpPr>
+        <p:grpSpPr>
+          <a:xfrm>
+            <a:off x="0" y="0"/>
+            <a:ext cx="9149272" cy="1576446"/>
+            <a:chOff x="0" y="0"/>
+            <a:chExt cx="12192002" cy="1576446"/>
           </a:xfrm>
-          <a:prstGeom prst="rect">
-            <a:avLst/>
-          </a:prstGeom>
-          <a:gradFill>
-            <a:gsLst>
-              <a:gs pos="0">
-                <a:srgbClr val="000000">
-                  <a:alpha val="96000"/>
-                </a:srgbClr>
-              </a:gs>
-              <a:gs pos="100000">
-                <a:schemeClr val="accent1">
-                  <a:lumMod val="75000"/>
-                </a:schemeClr>
-              </a:gs>
-            </a:gsLst>
-            <a:lin ang="8400000" scaled="0"/>
-          </a:gradFill>
-          <a:ln>
-            <a:noFill/>
-          </a:ln>
-        </p:spPr>
-        <p:style>
-          <a:lnRef idx="2">
-            <a:schemeClr val="accent1">
-              <a:shade val="50000"/>
-            </a:schemeClr>
-          </a:lnRef>
-          <a:fillRef idx="1">
-            <a:schemeClr val="accent1"/>
-          </a:fillRef>
-          <a:effectRef idx="0">
-            <a:schemeClr val="accent1"/>
-          </a:effectRef>
-          <a:fontRef idx="minor">
-            <a:schemeClr val="lt1"/>
-          </a:fontRef>
-        </p:style>
-        <p:txBody>
-          <a:bodyPr rtlCol="0" anchor="ctr"/>
-          <a:lstStyle/>
-          <a:p>
-            <a:pPr algn="ctr"/>
-            <a:endParaRPr lang="es-EC" noProof="0" dirty="0"/>
-          </a:p>
-        </p:txBody>
-      </p:sp>
-      <p:sp>
-        <p:nvSpPr>
-          <p:cNvPr id="13" name="Rectangle 12">
-            <a:extLst>
-              <a:ext uri="{FF2B5EF4-FFF2-40B4-BE49-F238E27FC236}">
-                <a16:creationId xmlns:a16="http://schemas.microsoft.com/office/drawing/2014/main" id="{AAD0DBB9-1A4B-4391-81D4-CB19F9AB918A}"/>
-              </a:ext>
-              <a:ext uri="{C183D7F6-B498-43B3-948B-1728B52AA6E4}">
-                <adec:decorative xmlns:adec="http://schemas.microsoft.com/office/drawing/2017/decorative" val="1"/>
-              </a:ext>
-            </a:extLst>
-          </p:cNvPr>
-          <p:cNvSpPr>
-            <a:spLocks noGrp="1" noRot="1" noChangeAspect="1" noMove="1" noResize="1" noEditPoints="1" noAdjustHandles="1" noChangeArrowheads="1" noChangeShapeType="1" noTextEdit="1"/>
-          </p:cNvSpPr>
-          <p:nvPr>
-            <p:extLst>
-              <p:ext uri="{386F3935-93C4-4BCD-93E2-E3B085C9AB24}">
-                <p16:designElem xmlns:p16="http://schemas.microsoft.com/office/powerpoint/2015/main" val="1"/>
-              </p:ext>
-            </p:extLst>
-          </p:nvPr>
-        </p:nvSpPr>
-        <p:spPr>
-          <a:xfrm rot="10800000" flipH="1">
-            <a:off x="6096642" y="0"/>
-            <a:ext cx="3047358" cy="1576412"/>
-          </a:xfrm>
-          <a:prstGeom prst="rect">
-            <a:avLst/>
-          </a:prstGeom>
-          <a:gradFill>
-            <a:gsLst>
-              <a:gs pos="19000">
-                <a:schemeClr val="accent1">
-                  <a:lumMod val="50000"/>
-                  <a:alpha val="68000"/>
-                </a:schemeClr>
-              </a:gs>
-              <a:gs pos="100000">
-                <a:schemeClr val="accent1">
-                  <a:alpha val="79000"/>
-                </a:schemeClr>
-              </a:gs>
-            </a:gsLst>
-            <a:lin ang="19200000" scaled="0"/>
-          </a:gradFill>
-          <a:ln>
-            <a:noFill/>
-          </a:ln>
-        </p:spPr>
-        <p:style>
-          <a:lnRef idx="2">
-            <a:schemeClr val="accent1">
-              <a:shade val="50000"/>
-            </a:schemeClr>
-          </a:lnRef>
-          <a:fillRef idx="1">
-            <a:schemeClr val="accent1"/>
-          </a:fillRef>
-          <a:effectRef idx="0">
-            <a:schemeClr val="accent1"/>
-          </a:effectRef>
-          <a:fontRef idx="minor">
-            <a:schemeClr val="lt1"/>
-          </a:fontRef>
-        </p:style>
-        <p:txBody>
-          <a:bodyPr rtlCol="0" anchor="ctr"/>
-          <a:lstStyle/>
-          <a:p>
-            <a:pPr algn="ctr"/>
-            <a:endParaRPr lang="es-EC" noProof="0" dirty="0"/>
-          </a:p>
-        </p:txBody>
-      </p:sp>
-      <p:sp>
-        <p:nvSpPr>
-          <p:cNvPr id="15" name="Rectangle 14">
-            <a:extLst>
-              <a:ext uri="{FF2B5EF4-FFF2-40B4-BE49-F238E27FC236}">
-                <a16:creationId xmlns:a16="http://schemas.microsoft.com/office/drawing/2014/main" id="{063BBA22-50EA-4C4D-BE05-F1CE4E63AA56}"/>
-              </a:ext>
-              <a:ext uri="{C183D7F6-B498-43B3-948B-1728B52AA6E4}">
-                <adec:decorative xmlns:adec="http://schemas.microsoft.com/office/drawing/2017/decorative" val="1"/>
-              </a:ext>
-            </a:extLst>
-          </p:cNvPr>
-          <p:cNvSpPr>
-            <a:spLocks noGrp="1" noRot="1" noChangeAspect="1" noMove="1" noResize="1" noEditPoints="1" noAdjustHandles="1" noChangeArrowheads="1" noChangeShapeType="1" noTextEdit="1"/>
-          </p:cNvSpPr>
-          <p:nvPr>
-            <p:extLst>
-              <p:ext uri="{386F3935-93C4-4BCD-93E2-E3B085C9AB24}">
-                <p16:designElem xmlns:p16="http://schemas.microsoft.com/office/powerpoint/2015/main" val="1"/>
-              </p:ext>
-            </p:extLst>
-          </p:nvPr>
-        </p:nvSpPr>
-        <p:spPr>
-          <a:xfrm rot="5400000">
-            <a:off x="3783777" y="-3783778"/>
-            <a:ext cx="1576446" cy="9144002"/>
-          </a:xfrm>
-          <a:prstGeom prst="rect">
-            <a:avLst/>
-          </a:prstGeom>
-          <a:gradFill>
-            <a:gsLst>
-              <a:gs pos="23000">
-                <a:schemeClr val="accent1">
-                  <a:alpha val="0"/>
-                </a:schemeClr>
-              </a:gs>
-              <a:gs pos="99000">
-                <a:srgbClr val="000000">
-                  <a:alpha val="74000"/>
-                </a:srgbClr>
-              </a:gs>
-            </a:gsLst>
-            <a:lin ang="20400000" scaled="0"/>
-          </a:gradFill>
-          <a:ln>
-            <a:noFill/>
-          </a:ln>
-        </p:spPr>
-        <p:style>
-          <a:lnRef idx="2">
-            <a:schemeClr val="accent1">
-              <a:shade val="50000"/>
-            </a:schemeClr>
-          </a:lnRef>
-          <a:fillRef idx="1">
-            <a:schemeClr val="accent1"/>
-          </a:fillRef>
-          <a:effectRef idx="0">
-            <a:schemeClr val="accent1"/>
-          </a:effectRef>
-          <a:fontRef idx="minor">
-            <a:schemeClr val="lt1"/>
-          </a:fontRef>
-        </p:style>
-        <p:txBody>
-          <a:bodyPr rtlCol="0" anchor="ctr"/>
-          <a:lstStyle/>
-          <a:p>
-            <a:pPr algn="ctr"/>
-            <a:endParaRPr lang="es-EC" noProof="0" dirty="0"/>
-          </a:p>
-        </p:txBody>
-      </p:sp>
+        </p:grpSpPr>
+        <p:sp>
+          <p:nvSpPr>
+            <p:cNvPr id="23" name="Rectangle 22">
+              <a:extLst>
+                <a:ext uri="{FF2B5EF4-FFF2-40B4-BE49-F238E27FC236}">
+                  <a16:creationId xmlns:a16="http://schemas.microsoft.com/office/drawing/2014/main" id="{033A715A-0686-440A-8F40-441B42A6605C}"/>
+                </a:ext>
+                <a:ext uri="{C183D7F6-B498-43B3-948B-1728B52AA6E4}">
+                  <adec:decorative xmlns:adec="http://schemas.microsoft.com/office/drawing/2017/decorative" val="1"/>
+                </a:ext>
+              </a:extLst>
+            </p:cNvPr>
+            <p:cNvSpPr/>
+            <p:nvPr>
+              <p:extLst>
+                <p:ext uri="{386F3935-93C4-4BCD-93E2-E3B085C9AB24}">
+                  <p16:designElem xmlns:p16="http://schemas.microsoft.com/office/powerpoint/2015/main" val="1"/>
+                </p:ext>
+              </p:extLst>
+            </p:nvPr>
+          </p:nvSpPr>
+          <p:spPr>
+            <a:xfrm rot="10800000" flipH="1">
+              <a:off x="2" y="0"/>
+              <a:ext cx="12191998" cy="1575955"/>
+            </a:xfrm>
+            <a:prstGeom prst="rect">
+              <a:avLst/>
+            </a:prstGeom>
+            <a:gradFill>
+              <a:gsLst>
+                <a:gs pos="0">
+                  <a:srgbClr val="000000">
+                    <a:alpha val="96000"/>
+                  </a:srgbClr>
+                </a:gs>
+                <a:gs pos="100000">
+                  <a:schemeClr val="accent1">
+                    <a:lumMod val="75000"/>
+                  </a:schemeClr>
+                </a:gs>
+              </a:gsLst>
+              <a:lin ang="8400000" scaled="0"/>
+            </a:gradFill>
+            <a:ln>
+              <a:noFill/>
+            </a:ln>
+          </p:spPr>
+          <p:style>
+            <a:lnRef idx="2">
+              <a:schemeClr val="accent1">
+                <a:shade val="50000"/>
+              </a:schemeClr>
+            </a:lnRef>
+            <a:fillRef idx="1">
+              <a:schemeClr val="accent1"/>
+            </a:fillRef>
+            <a:effectRef idx="0">
+              <a:schemeClr val="accent1"/>
+            </a:effectRef>
+            <a:fontRef idx="minor">
+              <a:schemeClr val="lt1"/>
+            </a:fontRef>
+          </p:style>
+          <p:txBody>
+            <a:bodyPr rtlCol="0" anchor="ctr"/>
+            <a:lstStyle/>
+            <a:p>
+              <a:pPr algn="ctr"/>
+              <a:endParaRPr lang="en-US"/>
+            </a:p>
+          </p:txBody>
+        </p:sp>
+        <p:sp>
+          <p:nvSpPr>
+            <p:cNvPr id="32" name="Rectangle 23">
+              <a:extLst>
+                <a:ext uri="{FF2B5EF4-FFF2-40B4-BE49-F238E27FC236}">
+                  <a16:creationId xmlns:a16="http://schemas.microsoft.com/office/drawing/2014/main" id="{4761657F-19F2-425B-B7E9-0118CD13C334}"/>
+                </a:ext>
+                <a:ext uri="{C183D7F6-B498-43B3-948B-1728B52AA6E4}">
+                  <adec:decorative xmlns:adec="http://schemas.microsoft.com/office/drawing/2017/decorative" val="1"/>
+                </a:ext>
+              </a:extLst>
+            </p:cNvPr>
+            <p:cNvSpPr/>
+            <p:nvPr>
+              <p:extLst>
+                <p:ext uri="{386F3935-93C4-4BCD-93E2-E3B085C9AB24}">
+                  <p16:designElem xmlns:p16="http://schemas.microsoft.com/office/powerpoint/2015/main" val="1"/>
+                </p:ext>
+              </p:extLst>
+            </p:nvPr>
+          </p:nvSpPr>
+          <p:spPr>
+            <a:xfrm rot="16200000">
+              <a:off x="5307778" y="-5307778"/>
+              <a:ext cx="1576446" cy="12192002"/>
+            </a:xfrm>
+            <a:prstGeom prst="rect">
+              <a:avLst/>
+            </a:prstGeom>
+            <a:gradFill>
+              <a:gsLst>
+                <a:gs pos="45000">
+                  <a:schemeClr val="accent1">
+                    <a:alpha val="0"/>
+                  </a:schemeClr>
+                </a:gs>
+                <a:gs pos="99000">
+                  <a:srgbClr val="000000">
+                    <a:alpha val="74000"/>
+                  </a:srgbClr>
+                </a:gs>
+              </a:gsLst>
+              <a:lin ang="11400000" scaled="0"/>
+            </a:gradFill>
+            <a:ln>
+              <a:noFill/>
+            </a:ln>
+          </p:spPr>
+          <p:style>
+            <a:lnRef idx="2">
+              <a:schemeClr val="accent1">
+                <a:shade val="50000"/>
+              </a:schemeClr>
+            </a:lnRef>
+            <a:fillRef idx="1">
+              <a:schemeClr val="accent1"/>
+            </a:fillRef>
+            <a:effectRef idx="0">
+              <a:schemeClr val="accent1"/>
+            </a:effectRef>
+            <a:fontRef idx="minor">
+              <a:schemeClr val="lt1"/>
+            </a:fontRef>
+          </p:style>
+          <p:txBody>
+            <a:bodyPr rtlCol="0" anchor="ctr"/>
+            <a:lstStyle/>
+            <a:p>
+              <a:pPr algn="ctr"/>
+              <a:endParaRPr lang="en-US" dirty="0"/>
+            </a:p>
+          </p:txBody>
+        </p:sp>
+        <p:sp>
+          <p:nvSpPr>
+            <p:cNvPr id="33" name="Rectangle 24">
+              <a:extLst>
+                <a:ext uri="{FF2B5EF4-FFF2-40B4-BE49-F238E27FC236}">
+                  <a16:creationId xmlns:a16="http://schemas.microsoft.com/office/drawing/2014/main" id="{E27B6634-79D3-4EDD-A77A-1065D6F3A4F2}"/>
+                </a:ext>
+                <a:ext uri="{C183D7F6-B498-43B3-948B-1728B52AA6E4}">
+                  <adec:decorative xmlns:adec="http://schemas.microsoft.com/office/drawing/2017/decorative" val="1"/>
+                </a:ext>
+              </a:extLst>
+            </p:cNvPr>
+            <p:cNvSpPr/>
+            <p:nvPr>
+              <p:extLst>
+                <p:ext uri="{386F3935-93C4-4BCD-93E2-E3B085C9AB24}">
+                  <p16:designElem xmlns:p16="http://schemas.microsoft.com/office/powerpoint/2015/main" val="1"/>
+                </p:ext>
+              </p:extLst>
+            </p:nvPr>
+          </p:nvSpPr>
+          <p:spPr>
+            <a:xfrm>
+              <a:off x="3825434" y="0"/>
+              <a:ext cx="4303422" cy="1575461"/>
+            </a:xfrm>
+            <a:prstGeom prst="rect">
+              <a:avLst/>
+            </a:prstGeom>
+            <a:gradFill>
+              <a:gsLst>
+                <a:gs pos="0">
+                  <a:schemeClr val="accent1">
+                    <a:alpha val="17000"/>
+                  </a:schemeClr>
+                </a:gs>
+                <a:gs pos="74000">
+                  <a:schemeClr val="accent1">
+                    <a:lumMod val="50000"/>
+                    <a:alpha val="0"/>
+                  </a:schemeClr>
+                </a:gs>
+              </a:gsLst>
+              <a:lin ang="14400000" scaled="0"/>
+            </a:gradFill>
+            <a:ln>
+              <a:noFill/>
+            </a:ln>
+          </p:spPr>
+          <p:style>
+            <a:lnRef idx="2">
+              <a:schemeClr val="accent1">
+                <a:shade val="50000"/>
+              </a:schemeClr>
+            </a:lnRef>
+            <a:fillRef idx="1">
+              <a:schemeClr val="accent1"/>
+            </a:fillRef>
+            <a:effectRef idx="0">
+              <a:schemeClr val="accent1"/>
+            </a:effectRef>
+            <a:fontRef idx="minor">
+              <a:schemeClr val="lt1"/>
+            </a:fontRef>
+          </p:style>
+          <p:txBody>
+            <a:bodyPr rtlCol="0" anchor="ctr"/>
+            <a:lstStyle/>
+            <a:p>
+              <a:pPr algn="ctr"/>
+              <a:endParaRPr lang="en-US"/>
+            </a:p>
+          </p:txBody>
+        </p:sp>
+      </p:grpSp>
       <p:sp>
         <p:nvSpPr>
           <p:cNvPr id="2" name="Title 1"/>
@@ -17929,8 +17788,8 @@
         </p:nvSpPr>
         <p:spPr>
           <a:xfrm>
-            <a:off x="1028697" y="348865"/>
-            <a:ext cx="7533018" cy="877729"/>
+            <a:off x="1028698" y="319314"/>
+            <a:ext cx="7108033" cy="1030515"/>
           </a:xfrm>
         </p:spPr>
         <p:txBody>
@@ -17940,28 +17799,12 @@
           <a:lstStyle/>
           <a:p>
             <a:r>
-              <a:rPr lang="es-EC" sz="3500" noProof="0" dirty="0" err="1">
+              <a:rPr lang="es-EC" sz="3500" noProof="0">
                 <a:solidFill>
                   <a:srgbClr val="FFFFFF"/>
                 </a:solidFill>
               </a:rPr>
-              <a:t>Datasheet</a:t>
-            </a:r>
-            <a:r>
-              <a:rPr lang="es-EC" sz="3500" noProof="0" dirty="0">
-                <a:solidFill>
-                  <a:srgbClr val="FFFFFF"/>
-                </a:solidFill>
-              </a:rPr>
-              <a:t>: Composición del </a:t>
-            </a:r>
-            <a:r>
-              <a:rPr lang="es-EC" sz="3500" noProof="0" dirty="0" err="1">
-                <a:solidFill>
-                  <a:srgbClr val="FFFFFF"/>
-                </a:solidFill>
-              </a:rPr>
-              <a:t>dataset</a:t>
+              <a:t>Datasheet: Composición del dataset</a:t>
             </a:r>
             <a:endParaRPr lang="es-EC" sz="3500" noProof="0" dirty="0">
               <a:solidFill>
@@ -17971,6 +17814,66 @@
           </a:p>
         </p:txBody>
       </p:sp>
+      <p:pic>
+        <p:nvPicPr>
+          <p:cNvPr id="7" name="Imagen 6">
+            <a:extLst>
+              <a:ext uri="{FF2B5EF4-FFF2-40B4-BE49-F238E27FC236}">
+                <a16:creationId xmlns:a16="http://schemas.microsoft.com/office/drawing/2014/main" id="{5F21F5AE-2BA6-779E-4147-78E278FFC161}"/>
+              </a:ext>
+            </a:extLst>
+          </p:cNvPr>
+          <p:cNvPicPr>
+            <a:picLocks noChangeAspect="1"/>
+          </p:cNvPicPr>
+          <p:nvPr/>
+        </p:nvPicPr>
+        <p:blipFill>
+          <a:blip r:embed="rId2"/>
+          <a:stretch>
+            <a:fillRect/>
+          </a:stretch>
+        </p:blipFill>
+        <p:spPr>
+          <a:xfrm>
+            <a:off x="4538747" y="2259088"/>
+            <a:ext cx="4605251" cy="1692428"/>
+          </a:xfrm>
+          <a:prstGeom prst="rect">
+            <a:avLst/>
+          </a:prstGeom>
+        </p:spPr>
+      </p:pic>
+      <p:pic>
+        <p:nvPicPr>
+          <p:cNvPr id="4" name="Imagen 3">
+            <a:extLst>
+              <a:ext uri="{FF2B5EF4-FFF2-40B4-BE49-F238E27FC236}">
+                <a16:creationId xmlns:a16="http://schemas.microsoft.com/office/drawing/2014/main" id="{EC18021D-08DE-10D1-DF20-4EE534A2CB5F}"/>
+              </a:ext>
+            </a:extLst>
+          </p:cNvPr>
+          <p:cNvPicPr>
+            <a:picLocks noChangeAspect="1"/>
+          </p:cNvPicPr>
+          <p:nvPr/>
+        </p:nvPicPr>
+        <p:blipFill>
+          <a:blip r:embed="rId3"/>
+          <a:stretch>
+            <a:fillRect/>
+          </a:stretch>
+        </p:blipFill>
+        <p:spPr>
+          <a:xfrm>
+            <a:off x="2" y="2259088"/>
+            <a:ext cx="4538745" cy="1703742"/>
+          </a:xfrm>
+          <a:prstGeom prst="rect">
+            <a:avLst/>
+          </a:prstGeom>
+        </p:spPr>
+      </p:pic>
       <p:graphicFrame>
         <p:nvGraphicFramePr>
           <p:cNvPr id="5" name="Content Placeholder 2">
@@ -17987,18 +17890,18 @@
             <p:ph idx="1"/>
             <p:extLst>
               <p:ext uri="{D42A27DB-BD31-4B8C-83A1-F6EECF244321}">
-                <p14:modId xmlns:p14="http://schemas.microsoft.com/office/powerpoint/2010/main" val="672049721"/>
+                <p14:modId xmlns:p14="http://schemas.microsoft.com/office/powerpoint/2010/main" val="1888129789"/>
               </p:ext>
             </p:extLst>
           </p:nvPr>
         </p:nvGraphicFramePr>
         <p:xfrm>
-          <a:off x="483042" y="2112579"/>
-          <a:ext cx="8195871" cy="4192805"/>
+          <a:off x="1028698" y="5070346"/>
+          <a:ext cx="7122320" cy="1385266"/>
         </p:xfrm>
         <a:graphic>
           <a:graphicData uri="http://schemas.openxmlformats.org/drawingml/2006/diagram">
-            <dgm:relIds xmlns:dgm="http://schemas.openxmlformats.org/drawingml/2006/diagram" xmlns:r="http://schemas.openxmlformats.org/officeDocument/2006/relationships" r:dm="rId2" r:lo="rId3" r:qs="rId4" r:cs="rId5"/>
+            <dgm:relIds xmlns:dgm="http://schemas.openxmlformats.org/drawingml/2006/diagram" xmlns:r="http://schemas.openxmlformats.org/officeDocument/2006/relationships" r:dm="rId4" r:lo="rId5" r:qs="rId6" r:cs="rId7"/>
           </a:graphicData>
         </a:graphic>
       </p:graphicFrame>
@@ -20411,36 +20314,6 @@
           </a:p>
         </p:txBody>
       </p:sp>
-      <p:pic>
-        <p:nvPicPr>
-          <p:cNvPr id="7" name="Imagen 6">
-            <a:extLst>
-              <a:ext uri="{FF2B5EF4-FFF2-40B4-BE49-F238E27FC236}">
-                <a16:creationId xmlns:a16="http://schemas.microsoft.com/office/drawing/2014/main" id="{2B687166-26CE-8E86-B556-A7BFDC0A8E6F}"/>
-              </a:ext>
-            </a:extLst>
-          </p:cNvPr>
-          <p:cNvPicPr>
-            <a:picLocks noChangeAspect="1"/>
-          </p:cNvPicPr>
-          <p:nvPr/>
-        </p:nvPicPr>
-        <p:blipFill>
-          <a:blip r:embed="rId2"/>
-          <a:stretch>
-            <a:fillRect/>
-          </a:stretch>
-        </p:blipFill>
-        <p:spPr>
-          <a:xfrm>
-            <a:off x="1892605" y="402570"/>
-            <a:ext cx="5358788" cy="3215273"/>
-          </a:xfrm>
-          <a:prstGeom prst="rect">
-            <a:avLst/>
-          </a:prstGeom>
-        </p:spPr>
-      </p:pic>
       <p:sp>
         <p:nvSpPr>
           <p:cNvPr id="3" name="Content Placeholder 2"/>
@@ -20490,6 +20363,36 @@
           </a:p>
         </p:txBody>
       </p:sp>
+      <p:pic>
+        <p:nvPicPr>
+          <p:cNvPr id="5" name="Imagen 4">
+            <a:extLst>
+              <a:ext uri="{FF2B5EF4-FFF2-40B4-BE49-F238E27FC236}">
+                <a16:creationId xmlns:a16="http://schemas.microsoft.com/office/drawing/2014/main" id="{A17AE9B2-D808-60E3-8884-27426009AFDE}"/>
+              </a:ext>
+            </a:extLst>
+          </p:cNvPr>
+          <p:cNvPicPr>
+            <a:picLocks noChangeAspect="1"/>
+          </p:cNvPicPr>
+          <p:nvPr/>
+        </p:nvPicPr>
+        <p:blipFill>
+          <a:blip r:embed="rId2"/>
+          <a:stretch>
+            <a:fillRect/>
+          </a:stretch>
+        </p:blipFill>
+        <p:spPr>
+          <a:xfrm>
+            <a:off x="1455192" y="314078"/>
+            <a:ext cx="6233616" cy="3645883"/>
+          </a:xfrm>
+          <a:prstGeom prst="rect">
+            <a:avLst/>
+          </a:prstGeom>
+        </p:spPr>
+      </p:pic>
     </p:spTree>
   </p:cSld>
   <p:clrMapOvr>

</xml_diff>